<commit_message>
Finalize Phase 2 deployment documentation and presentation
</commit_message>
<xml_diff>
--- a/presentation/MAI201_Phase2_Final_Presentation.pptx
+++ b/presentation/MAI201_Phase2_Final_Presentation.pptx
@@ -1271,7 +1271,7 @@
           <a:p>
             <a:r>
               <a:rPr lang="en-US" dirty="0"/>
-              <a:t>SOMEYAH (0:40 plus about 1:30 of demo). Let me show it working. [Demo: open the public Swagger page, call health and show model_loaded true, post the fraud transaction and show the 0.9696 probability, then the GitHub Actions run with lint, tests, the container smoke test and the deploy step, and finally the Evidently report with 17 of 30 columns flagged.] To close: Phase 1 gave us a model we could reproduce. Phase 2 turned it into a service we can run, test, deploy and watch. If we carried this further, the three things we would do are set the decision threshold from the actual cost of a missed fraud versus a false alarm, log real requests so drift is measured on live traffic instead of a simulation, and put the drift check on a schedule. Thank you — we are happy to take questions.</a:t>
+              <a:t>SOMEYAH (0:40 plus about 1:30 of demo). Let me show it working. [Demo: open the public Swagger page, call health and show model_loaded true, post the fraud transaction and show the 0.9696 probability, then the legitimate one at 0.000235, then the GitHub Actions run for commit 363892b with all three jobs green, and finally the Evidently report with 17 of 30 columns flagged.] To close: Phase 1 gave us a model we could reproduce. Phase 2 turned it into a service we can run, test, deploy and watch. If we carried this further, the three things we would do are set the decision threshold from the actual cost of a missed fraud versus a false alarm, log real requests so drift is measured on live traffic instead of a simulation, and put the drift check on a schedule. Thank you — we are happy to take questions.</a:t>
             </a:r>
             <a:endParaRPr lang="en-US" dirty="0"/>
           </a:p>
@@ -1711,7 +1711,7 @@
           <a:p>
             <a:r>
               <a:rPr lang="en-US" dirty="0"/>
-              <a:t>MOHAMED (0:55). The container is deliberately small. It starts from python 3.11-slim and installs only what serving needs — FastAPI, Uvicorn, scikit-learn, pandas, numpy. DVC, MLflow and Evidently are training and monitoring tools, so they stay out of the image. requirements-api.txt is fully pinned, and that matters more than it sounds: model.pkl is a pickled scikit-learn object, so the container has to install the same version that fitted it, otherwise loading it is a gamble. The container runs as a non-root user, holds no secrets, and listens on the port Render injects. It is deployed on Render as a Docker web service with the health check pointed at /health, and that is the public URL on the screen. We will hit it live in a moment.</a:t>
+              <a:t>MOHAMED (0:55). The container is deliberately small. It starts from python 3.11-slim and installs only what serving needs — FastAPI, Uvicorn, scikit-learn, pandas, numpy. DVC, MLflow and Evidently are training and monitoring tools, so they stay out of the image. requirements-api.txt is fully pinned, and that matters more than it sounds: model.pkl is a pickled scikit-learn object, so the container has to install the same version that fitted it, otherwise loading it is a gamble. The container runs as a non-root user, holds no secrets, and listens on the port Render injects. It is deployed on Render as a Docker web service with the health check pointed at /health, and that is the public URL on the screen. It is live right now: /health comes back healthy, with model_loaded true and the model path inside the container. This version was released by the CI/CD pipeline, not by anyone clicking deploy. We will hit it live in a moment.</a:t>
             </a:r>
             <a:endParaRPr lang="en-US" dirty="0"/>
           </a:p>
@@ -1799,7 +1799,7 @@
           <a:p>
             <a:r>
               <a:rPr lang="en-US" dirty="0"/>
-              <a:t>MOHAMED (0:50). The workflow is one file, .github/workflows/ci-cd.yml, and it runs on every push and every pull request. Four things happen in order. Ruff lints the whole repository. Pytest runs our 34 tests against the real model artifact, not a stub. Then Docker builds the image — and this is the part I want to highlight — CI does not just build it, it starts the container, waits for it, checks that health reports the model as loaded, posts a real transaction to predict and asserts the probability is in range, and sends a broken payload to confirm it gets a 422. Only if all of that passes, and only on the main branch, does the deploy job fire the Render deploy hook, which is stored as a GitHub secret and never appears in the code. We deliberately turned Render's own auto-deploy off, so nothing reaches production without passing CI first.</a:t>
+              <a:t>MOHAMED (0:50). The workflow is one file, .github/workflows/ci-cd.yml, and it runs on every push and every pull request. Four things happen in order. Ruff lints the whole repository. Pytest runs our 34 tests against the real model artifact, not a stub. Then Docker builds the image — and this is the part I want to highlight — CI does not just build it, it starts the container, waits for it, checks that health reports the model as loaded, posts a real transaction to predict and asserts the probability is in range, and sends a broken payload to confirm it gets a 422. Only if all of that passes, and only on the main branch, does the deploy job fire the Render deploy hook, which is stored as a GitHub secret and never appears in the code. We deliberately turned Render's own auto-deploy off, so nothing reaches production without passing CI first. The run you can see on screen is commit 363892b, where all three jobs passed and the deploy job released the version that is serving right now.</a:t>
             </a:r>
             <a:endParaRPr lang="en-US" dirty="0"/>
           </a:p>
@@ -4303,7 +4303,7 @@
                 <a:ea typeface="Courier New" pitchFamily="34" charset="-122"/>
                 <a:cs typeface="Courier New" pitchFamily="34" charset="-120"/>
               </a:rPr>
-              <a:t>lint, tests, container smoke test, deploy</a:t>
+              <a:t>commit 363892b — all three jobs green</a:t>
             </a:r>
             <a:endParaRPr lang="en-US" sz="1000" dirty="0"/>
           </a:p>
@@ -7607,7 +7607,7 @@
       </p:sp>
       <p:pic>
         <p:nvPicPr>
-          <p:cNvPr id="5" name="Image 0" descr="/tmp/work/repo/docs/architecture_phase2.png">    </p:cNvPr>
+          <p:cNvPr id="5" name="Image 0" descr="/sessions/focused-compassionate-galileo/mnt/mlops-creditcard/docs/architecture_phase2.png">    </p:cNvPr>
           <p:cNvPicPr>
             <a:picLocks noChangeAspect="1"/>
           </p:cNvPicPr>
@@ -9622,14 +9622,67 @@
       </p:sp>
       <p:sp>
         <p:nvSpPr>
-          <p:cNvPr id="26" name="Text 24"/>
-          <p:cNvSpPr/>
-          <p:nvPr/>
-        </p:nvSpPr>
-        <p:spPr>
-          <a:xfrm>
-            <a:off x="1005840" y="4526280"/>
-            <a:ext cx="3657600" cy="292608"/>
+          <p:cNvPr id="26" name="Shape 24"/>
+          <p:cNvSpPr/>
+          <p:nvPr/>
+        </p:nvSpPr>
+        <p:spPr>
+          <a:xfrm>
+            <a:off x="1005840" y="4507992"/>
+            <a:ext cx="274320" cy="274320"/>
+          </a:xfrm>
+          <a:prstGeom prst="ellipse">
+            <a:avLst/>
+          </a:prstGeom>
+          <a:solidFill>
+            <a:srgbClr val="1E7A50"/>
+          </a:solidFill>
+          <a:ln w="12700">
+            <a:solidFill>
+              <a:srgbClr val="1E7A50"/>
+            </a:solidFill>
+            <a:prstDash val="solid"/>
+          </a:ln>
+        </p:spPr>
+      </p:sp>
+      <p:sp>
+        <p:nvSpPr>
+          <p:cNvPr id="27" name="Text 25"/>
+          <p:cNvSpPr/>
+          <p:nvPr/>
+        </p:nvSpPr>
+        <p:spPr>
+          <a:xfrm>
+            <a:off x="1005840" y="4507992"/>
+            <a:ext cx="274320" cy="274320"/>
+          </a:xfrm>
+          <a:prstGeom prst="rect">
+            <a:avLst/>
+          </a:prstGeom>
+          <a:noFill/>
+          <a:ln/>
+        </p:spPr>
+        <p:txBody>
+          <a:bodyPr wrap="square" lIns="0" tIns="0" rIns="0" bIns="0" rtlCol="0" anchor="ctr"/>
+          <a:lstStyle/>
+          <a:p>
+            <a:pPr algn="ctr" indent="0" marL="0">
+              <a:buNone/>
+            </a:pPr>
+            <a:endParaRPr lang="en-US" sz="1200" dirty="0"/>
+          </a:p>
+        </p:txBody>
+      </p:sp>
+      <p:sp>
+        <p:nvSpPr>
+          <p:cNvPr id="28" name="Text 26"/>
+          <p:cNvSpPr/>
+          <p:nvPr/>
+        </p:nvSpPr>
+        <p:spPr>
+          <a:xfrm>
+            <a:off x="1389888" y="4480560"/>
+            <a:ext cx="3657600" cy="310896"/>
           </a:xfrm>
           <a:prstGeom prst="rect">
             <a:avLst/>
@@ -9661,13 +9714,13 @@
       </p:sp>
       <p:sp>
         <p:nvSpPr>
-          <p:cNvPr id="27" name="Text 25"/>
-          <p:cNvSpPr/>
-          <p:nvPr/>
-        </p:nvSpPr>
-        <p:spPr>
-          <a:xfrm>
-            <a:off x="1005840" y="4846320"/>
+          <p:cNvPr id="29" name="Text 27"/>
+          <p:cNvSpPr/>
+          <p:nvPr/>
+        </p:nvSpPr>
+        <p:spPr>
+          <a:xfrm>
+            <a:off x="1005840" y="4809744"/>
             <a:ext cx="10149840" cy="457200"/>
           </a:xfrm>
           <a:prstGeom prst="rect">
@@ -9700,14 +9753,14 @@
       </p:sp>
       <p:sp>
         <p:nvSpPr>
-          <p:cNvPr id="28" name="Text 26"/>
-          <p:cNvSpPr/>
-          <p:nvPr/>
-        </p:nvSpPr>
-        <p:spPr>
-          <a:xfrm>
-            <a:off x="1005840" y="5394960"/>
-            <a:ext cx="10149840" cy="365760"/>
+          <p:cNvPr id="30" name="Text 28"/>
+          <p:cNvSpPr/>
+          <p:nvPr/>
+        </p:nvSpPr>
+        <p:spPr>
+          <a:xfrm>
+            <a:off x="1005840" y="5321808"/>
+            <a:ext cx="10149840" cy="310896"/>
           </a:xfrm>
           <a:prstGeom prst="rect">
             <a:avLst/>
@@ -9723,17 +9776,56 @@
               <a:buNone/>
             </a:pPr>
             <a:r>
-              <a:rPr lang="en-US" sz="1200" dirty="0">
+              <a:rPr lang="en-US" sz="1050" dirty="0">
                 <a:solidFill>
                   <a:srgbClr val="CADCFC"/>
                 </a:solidFill>
-                <a:latin typeface="Calibri" pitchFamily="34" charset="0"/>
-                <a:ea typeface="Calibri" pitchFamily="34" charset="-122"/>
-                <a:cs typeface="Calibri" pitchFamily="34" charset="-120"/>
-              </a:rPr>
-              <a:t>Swagger UI at https://mai201-fraud-api.onrender.com/docs   ·   health check at https://mai201-fraud-api.onrender.com/health</a:t>
-            </a:r>
-            <a:endParaRPr lang="en-US" sz="1200" dirty="0"/>
+                <a:latin typeface="Courier New" pitchFamily="34" charset="0"/>
+                <a:ea typeface="Courier New" pitchFamily="34" charset="-122"/>
+                <a:cs typeface="Courier New" pitchFamily="34" charset="-120"/>
+              </a:rPr>
+              <a:t>/health  -&gt;  {"status":"healthy","model_loaded":true,"model_path":"/srv/app/models/model.pkl"}</a:t>
+            </a:r>
+            <a:endParaRPr lang="en-US" sz="1050" dirty="0"/>
+          </a:p>
+        </p:txBody>
+      </p:sp>
+      <p:sp>
+        <p:nvSpPr>
+          <p:cNvPr id="31" name="Text 29"/>
+          <p:cNvSpPr/>
+          <p:nvPr/>
+        </p:nvSpPr>
+        <p:spPr>
+          <a:xfrm>
+            <a:off x="1005840" y="5650992"/>
+            <a:ext cx="10149840" cy="310896"/>
+          </a:xfrm>
+          <a:prstGeom prst="rect">
+            <a:avLst/>
+          </a:prstGeom>
+          <a:noFill/>
+          <a:ln/>
+        </p:spPr>
+        <p:txBody>
+          <a:bodyPr wrap="square" lIns="0" tIns="0" rIns="0" bIns="0" rtlCol="0" anchor="ctr"/>
+          <a:lstStyle/>
+          <a:p>
+            <a:pPr indent="0" marL="0">
+              <a:buNone/>
+            </a:pPr>
+            <a:r>
+              <a:rPr lang="en-US" sz="1100" dirty="0">
+                <a:solidFill>
+                  <a:srgbClr val="8FA6C4"/>
+                </a:solidFill>
+                <a:latin typeface="Calibri" pitchFamily="34" charset="0"/>
+                <a:ea typeface="Calibri" pitchFamily="34" charset="-122"/>
+                <a:cs typeface="Calibri" pitchFamily="34" charset="-120"/>
+              </a:rPr>
+              <a:t>Swagger UI at https://mai201-fraud-api.onrender.com/docs   ·   released by CI/CD from commit 363892b</a:t>
+            </a:r>
+            <a:endParaRPr lang="en-US" sz="1100" dirty="0"/>
           </a:p>
         </p:txBody>
       </p:sp>
@@ -10676,11 +10768,11 @@
         <p:spPr>
           <a:xfrm>
             <a:off x="685800" y="3474720"/>
-            <a:ext cx="5349240" cy="2651760"/>
+            <a:ext cx="5349240" cy="2487168"/>
           </a:xfrm>
           <a:prstGeom prst="roundRect">
             <a:avLst>
-              <a:gd name="adj" fmla="val 3103"/>
+              <a:gd name="adj" fmla="val 3309"/>
             </a:avLst>
           </a:prstGeom>
           <a:solidFill>
@@ -10827,11 +10919,11 @@
         <p:spPr>
           <a:xfrm>
             <a:off x="6400800" y="3474720"/>
-            <a:ext cx="5120640" cy="2651760"/>
+            <a:ext cx="5120640" cy="2487168"/>
           </a:xfrm>
           <a:prstGeom prst="roundRect">
             <a:avLst>
-              <a:gd name="adj" fmla="val 3103"/>
+              <a:gd name="adj" fmla="val 3309"/>
             </a:avLst>
           </a:prstGeom>
           <a:solidFill>
@@ -11176,7 +11268,7 @@
         </p:nvSpPr>
         <p:spPr>
           <a:xfrm>
-            <a:off x="6675120" y="5623560"/>
+            <a:off x="6675120" y="5596128"/>
             <a:ext cx="4572000" cy="411480"/>
           </a:xfrm>
           <a:prstGeom prst="rect">
@@ -11204,6 +11296,72 @@
               <a:t>Render auto-deploy is switched off on purpose — CI is the only route to production.</a:t>
             </a:r>
             <a:endParaRPr lang="en-US" sz="1050" dirty="0"/>
+          </a:p>
+        </p:txBody>
+      </p:sp>
+      <p:sp>
+        <p:nvSpPr>
+          <p:cNvPr id="42" name="Shape 40"/>
+          <p:cNvSpPr/>
+          <p:nvPr/>
+        </p:nvSpPr>
+        <p:spPr>
+          <a:xfrm>
+            <a:off x="685800" y="6181344"/>
+            <a:ext cx="10835640" cy="384048"/>
+          </a:xfrm>
+          <a:prstGeom prst="roundRect">
+            <a:avLst>
+              <a:gd name="adj" fmla="val 21429"/>
+            </a:avLst>
+          </a:prstGeom>
+          <a:solidFill>
+            <a:srgbClr val="E7F3EC"/>
+          </a:solidFill>
+          <a:ln w="12700">
+            <a:solidFill>
+              <a:srgbClr val="E7F3EC"/>
+            </a:solidFill>
+            <a:prstDash val="solid"/>
+          </a:ln>
+        </p:spPr>
+      </p:sp>
+      <p:sp>
+        <p:nvSpPr>
+          <p:cNvPr id="43" name="Text 41"/>
+          <p:cNvSpPr/>
+          <p:nvPr/>
+        </p:nvSpPr>
+        <p:spPr>
+          <a:xfrm>
+            <a:off x="960120" y="6181344"/>
+            <a:ext cx="10287000" cy="384048"/>
+          </a:xfrm>
+          <a:prstGeom prst="rect">
+            <a:avLst/>
+          </a:prstGeom>
+          <a:noFill/>
+          <a:ln/>
+        </p:spPr>
+        <p:txBody>
+          <a:bodyPr wrap="square" lIns="0" tIns="0" rIns="0" bIns="0" rtlCol="0" anchor="ctr"/>
+          <a:lstStyle/>
+          <a:p>
+            <a:pPr indent="0" marL="0">
+              <a:buNone/>
+            </a:pPr>
+            <a:r>
+              <a:rPr lang="en-US" sz="1100" b="1" dirty="0">
+                <a:solidFill>
+                  <a:srgbClr val="1E7A50"/>
+                </a:solidFill>
+                <a:latin typeface="Calibri" pitchFamily="34" charset="0"/>
+                <a:ea typeface="Calibri" pitchFamily="34" charset="-122"/>
+                <a:cs typeface="Calibri" pitchFamily="34" charset="-120"/>
+              </a:rPr>
+              <a:t>All three jobs green on commit 363892b — lint and test, build and smoke-test the image, deploy to Render.</a:t>
+            </a:r>
+            <a:endParaRPr lang="en-US" sz="1100" dirty="0"/>
           </a:p>
         </p:txBody>
       </p:sp>

</xml_diff>

<commit_message>
Finalize Phase 2 documentation and monitoring consistency
</commit_message>
<xml_diff>
--- a/presentation/MAI201_Phase2_Final_Presentation.pptx
+++ b/presentation/MAI201_Phase2_Final_Presentation.pptx
@@ -1271,7 +1271,7 @@
           <a:p>
             <a:r>
               <a:rPr lang="en-US" dirty="0"/>
-              <a:t>SOMEYAH (0:40 plus about 1:30 of demo). Let me show it working. [Demo: open the public Swagger page, call health and show model_loaded true, post the fraud transaction and show the 0.9696 probability, then the legitimate one at 0.000235, then the GitHub Actions run for commit 363892b with all three jobs green, and finally the Evidently report with 17 of 30 columns flagged.] To close: Phase 1 gave us a model we could reproduce. Phase 2 turned it into a service we can run, test, deploy and watch. If we carried this further, the three things we would do are set the decision threshold from the actual cost of a missed fraud versus a false alarm, log real requests so drift is measured on live traffic instead of a simulation, and put the drift check on a schedule. Thank you — we are happy to take questions.</a:t>
+              <a:t>SOMEYAH (0:40 plus about 1:30 of demo). Let me show it working. [Demo: open the public Swagger page, call health and show model_loaded true, post the fraud transaction and show the 0.9696 probability, then the legitimate one at 0.000235, then the latest successful GitHub Actions run with all three jobs green, and finally the Evidently report with 17 of 30 columns flagged.] To close: Phase 1 gave us a model we could reproduce. Phase 2 turned it into a service we can run, test, deploy and watch. If we carried this further, the three things we would do are set the decision threshold from the actual cost of a missed fraud versus a false alarm, log real requests so drift is measured on live traffic instead of a simulation, and put the drift check on a schedule. Thank you — we are happy to take questions.</a:t>
             </a:r>
             <a:endParaRPr lang="en-US" dirty="0"/>
           </a:p>
@@ -1799,7 +1799,7 @@
           <a:p>
             <a:r>
               <a:rPr lang="en-US" dirty="0"/>
-              <a:t>MOHAMED (0:50). The workflow is one file, .github/workflows/ci-cd.yml, and it runs on every push and every pull request. Four things happen in order. Ruff lints the whole repository. Pytest runs our 34 tests against the real model artifact, not a stub. Then Docker builds the image — and this is the part I want to highlight — CI does not just build it, it starts the container, waits for it, checks that health reports the model as loaded, posts a real transaction to predict and asserts the probability is in range, and sends a broken payload to confirm it gets a 422. Only if all of that passes, and only on the main branch, does the deploy job fire the Render deploy hook, which is stored as a GitHub secret and never appears in the code. We deliberately turned Render's own auto-deploy off, so nothing reaches production without passing CI first. The run you can see on screen is commit 363892b, where all three jobs passed and the deploy job released the version that is serving right now.</a:t>
+              <a:t>MOHAMED (0:50). The workflow is one file, .github/workflows/ci-cd.yml, and it runs on every push and every pull request. Four things happen in order. Ruff lints the whole repository. Pytest runs our 34 tests against the real model artifact, not a stub. Then Docker builds the image — and this is the part I want to highlight — CI does not just build it, it starts the container, waits for it, checks that health reports the model as loaded, posts a real transaction to predict and asserts the probability is in range, and sends a broken payload to confirm it gets a 422. Only if all of that passes, and only on the main branch, does the deploy job fire the Render deploy hook, which is stored as a GitHub secret and never appears in the code. We deliberately turned Render's own auto-deploy off, so nothing reaches production without passing CI first. The run on screen is the latest successful one on main, where all three jobs passed and the deploy job released the version that is serving right now.</a:t>
             </a:r>
             <a:endParaRPr lang="en-US" dirty="0"/>
           </a:p>
@@ -1887,7 +1887,7 @@
           <a:p>
             <a:r>
               <a:rPr lang="en-US" dirty="0"/>
-              <a:t>SOMEYAH (1:00). Monitoring answers one question: is the traffic still shaped like what the model learned from? We use EvidentlyAI with the DataDriftPreset over the 30 input features. The reference is a fixed 10,000-row sample of the training split. We exclude Class, because the API never receives a label at prediction time. We ran two scenarios. The first is a control: untouched rows from the test split. Evidently flags zero of 30 columns — no drift, which tells us the monitor is not just alarmed by everything. The second is a deliberately drifted batch: we applied a seeded shift to 17 columns, simulating larger amounts, later timestamps and moved components. Evidently caught exactly those 17, a share of 0.567, which is above the 0.5 threshold, so it reports dataset drift. I want to be clear that this second batch is simulated for demonstration and labelled that way in the repository — we do not have real production traffic. Both reports are committed as HTML plus a JSON summary.</a:t>
+              <a:t>SOMEYAH (1:00). Monitoring answers one question: is the traffic still shaped like what the model learned from? We use EvidentlyAI with the DataDriftPreset over the 30 input features. The reference is a fixed 10,000-row sample of the training split. We exclude Class, because the API never receives a label at prediction time. Evidently picks the test itself from the data - at these batch sizes it chose normalized Wasserstein distance with a threshold of 0.1, and that choice is recorded in our JSON summary next to every score. We ran two scenarios. The first is a control: untouched rows from the test split. Evidently flags zero of 30 columns — no drift, which tells us the monitor is not just alarmed by everything. The second is a deliberately drifted batch: we applied a seeded shift to 17 columns, simulating larger amounts, later timestamps and moved components. Evidently caught exactly those 17, a share of 0.567, which is above the 0.5 threshold, so it reports dataset drift. I want to be clear that this second batch is simulated for demonstration and labelled that way in the repository — we do not have real production traffic. Both reports are committed as HTML plus a JSON summary.</a:t>
             </a:r>
             <a:endParaRPr lang="en-US" dirty="0"/>
           </a:p>
@@ -4303,7 +4303,7 @@
                 <a:ea typeface="Courier New" pitchFamily="34" charset="-122"/>
                 <a:cs typeface="Courier New" pitchFamily="34" charset="-120"/>
               </a:rPr>
-              <a:t>commit 363892b — all three jobs green</a:t>
+              <a:t>latest main-branch run — all three jobs green</a:t>
             </a:r>
             <a:endParaRPr lang="en-US" sz="1000" dirty="0"/>
           </a:p>
@@ -9823,7 +9823,7 @@
                 <a:ea typeface="Calibri" pitchFamily="34" charset="-122"/>
                 <a:cs typeface="Calibri" pitchFamily="34" charset="-120"/>
               </a:rPr>
-              <a:t>Swagger UI at https://mai201-fraud-api.onrender.com/docs   ·   released by CI/CD from commit 363892b</a:t>
+              <a:t>Swagger UI at https://mai201-fraud-api.onrender.com/docs   ·   released automatically by the latest successful CI/CD run</a:t>
             </a:r>
             <a:endParaRPr lang="en-US" sz="1100" dirty="0"/>
           </a:p>
@@ -11359,7 +11359,7 @@
                 <a:ea typeface="Calibri" pitchFamily="34" charset="-122"/>
                 <a:cs typeface="Calibri" pitchFamily="34" charset="-120"/>
               </a:rPr>
-              <a:t>All three jobs green on commit 363892b — lint and test, build and smoke-test the image, deploy to Render.</a:t>
+              <a:t>Latest main-branch CI/CD run — all three jobs green: lint and test, build and smoke-test the image, deploy to Render.</a:t>
             </a:r>
             <a:endParaRPr lang="en-US" sz="1100" dirty="0"/>
           </a:p>
@@ -11592,8 +11592,8 @@
         </p:nvSpPr>
         <p:spPr>
           <a:xfrm>
-            <a:off x="960120" y="4800600"/>
-            <a:ext cx="4846320" cy="1188720"/>
+            <a:off x="960120" y="4773168"/>
+            <a:ext cx="4846320" cy="1298448"/>
           </a:xfrm>
           <a:prstGeom prst="rect">
             <a:avLst/>
@@ -11607,12 +11607,12 @@
           <a:p>
             <a:pPr indent="0" marL="0">
               <a:lnSpc>
-                <a:spcPts val="1500"/>
+                <a:spcPts val="1300"/>
               </a:lnSpc>
               <a:buNone/>
             </a:pPr>
             <a:r>
-              <a:rPr lang="en-US" sz="1100" dirty="0">
+              <a:rPr lang="en-US" sz="1020" dirty="0">
                 <a:solidFill>
                   <a:srgbClr val="5A6B7D"/>
                 </a:solidFill>
@@ -11622,17 +11622,17 @@
               </a:rPr>
               <a:t>Reference: a fixed 10,000-row sample of the training split.</a:t>
             </a:r>
-            <a:endParaRPr lang="en-US" sz="1100" dirty="0"/>
+            <a:endParaRPr lang="en-US" sz="1020" dirty="0"/>
           </a:p>
           <a:p>
             <a:pPr indent="0" marL="0">
               <a:lnSpc>
-                <a:spcPts val="1500"/>
+                <a:spcPts val="1300"/>
               </a:lnSpc>
               <a:buNone/>
             </a:pPr>
             <a:r>
-              <a:rPr lang="en-US" sz="1100" dirty="0">
+              <a:rPr lang="en-US" sz="1020" dirty="0">
                 <a:solidFill>
                   <a:srgbClr val="5A6B7D"/>
                 </a:solidFill>
@@ -11642,17 +11642,17 @@
               </a:rPr>
               <a:t>Current: 5,000 production-shaped rows.</a:t>
             </a:r>
-            <a:endParaRPr lang="en-US" sz="1100" dirty="0"/>
+            <a:endParaRPr lang="en-US" sz="1020" dirty="0"/>
           </a:p>
           <a:p>
             <a:pPr indent="0" marL="0">
               <a:lnSpc>
-                <a:spcPts val="1500"/>
+                <a:spcPts val="1300"/>
               </a:lnSpc>
               <a:buNone/>
             </a:pPr>
             <a:r>
-              <a:rPr lang="en-US" sz="1100" dirty="0">
+              <a:rPr lang="en-US" sz="1020" dirty="0">
                 <a:solidFill>
                   <a:srgbClr val="5A6B7D"/>
                 </a:solidFill>
@@ -11660,9 +11660,9 @@
                 <a:ea typeface="Calibri" pitchFamily="34" charset="-122"/>
                 <a:cs typeface="Calibri" pitchFamily="34" charset="-120"/>
               </a:rPr>
-              <a:t>30 features compared with a K-S test; Class is excluded because the API never sees a label.</a:t>
-            </a:r>
-            <a:endParaRPr lang="en-US" sz="1100" dirty="0"/>
+              <a:t>30 numeric features compared with Evidently's DataDriftPreset. In the generated reports Evidently selected normalized Wasserstein distance, threshold 0.1. Class is excluded because the API never receives the label.</a:t>
+            </a:r>
+            <a:endParaRPr lang="en-US" sz="1020" dirty="0"/>
           </a:p>
         </p:txBody>
       </p:sp>

</xml_diff>

<commit_message>
Add live demo UI and finalize Phase 2 submission
</commit_message>
<xml_diff>
--- a/presentation/MAI201_Phase2_Final_Presentation.pptx
+++ b/presentation/MAI201_Phase2_Final_Presentation.pptx
@@ -1271,7 +1271,7 @@
           <a:p>
             <a:r>
               <a:rPr lang="en-US" dirty="0"/>
-              <a:t>SOMEYAH (0:40 plus about 1:30 of demo). Let me show it working. [Demo: open the public Swagger page, call health and show model_loaded true, post the fraud transaction and show the 0.9696 probability, then the legitimate one at 0.000235, then the latest successful GitHub Actions run with all three jobs green, and finally the Evidently report with 17 of 30 columns flagged.] To close: Phase 1 gave us a model we could reproduce. Phase 2 turned it into a service we can run, test, deploy and watch. If we carried this further, the three things we would do are set the decision threshold from the actual cost of a missed fraud versus a false alarm, log real requests so drift is measured on live traffic instead of a simulation, and put the drift check on a schedule. Thank you — we are happy to take questions.</a:t>
+              <a:t>SOMEYAH (0:40 plus about 1:30 of demo). Let me show it working. [Demo: open the public browser demo, call health and show model_loaded true, analyze the fraud transaction and show the 0.9696 probability, then the legitimate one at 0.000235, then the latest successful GitHub Actions run with all three jobs green, and finally the Evidently report with 17 of 30 columns flagged.] To close: Phase 1 gave us a model we could reproduce. Phase 2 turned it into a service we can run, test, deploy and watch. If we carried this further, the three things we would do are set the decision threshold from the actual cost of a missed fraud versus a false alarm, log real requests so drift is measured on live traffic instead of a simulation, and put the drift check on a schedule. Thank you — we are happy to take questions.</a:t>
             </a:r>
             <a:endParaRPr lang="en-US" dirty="0"/>
           </a:p>
@@ -1623,7 +1623,7 @@
           <a:p>
             <a:r>
               <a:rPr lang="en-US" dirty="0"/>
-              <a:t>ABDULRAOUF (0:55). The API exposes five routes. Health is the one worth calling out: it returns 200 only when the model actually loaded, and 503 otherwise. A health check that says healthy while the service cannot score anything is worse than no health check at all. Predict takes exactly the 30 training features, validated by Pydantic — a missing field, a wrong type, or an extra field like Class all come back as 422. Two implementation details. First, we serve the entire scikit-learn Pipeline, not just the classifier, so the Time and Amount scaling at inference is byte-for-byte what it was at training. Second, the model is loaded once at startup and reused. On the right is a real request and the real response: a fraud row from our test split, scored at 0.9696.</a:t>
+              <a:t>ABDULRAOUF (0:55). The API exposes five routes. Health is the one worth calling out: it returns 200 only when the model actually loaded, and 503 otherwise. A health check that says healthy while the service cannot score anything is worse than no health check at all. Predict takes exactly the 30 training features, validated by Pydantic — a missing field, a wrong type, or an extra field like Class all come back as 422. Two implementation details. First, we serve the entire scikit-learn Pipeline, not just the classifier, so the Time and Amount scaling at inference is byte-for-byte what it was at training. Second, the model is loaded once at startup and reused. On the right is a real request and the real response: a fraud row from our test split, scored at 0.9696. The service root also serves a small browser dashboard that posts to this same endpoint, and that is what we will demo.</a:t>
             </a:r>
             <a:endParaRPr lang="en-US" dirty="0"/>
           </a:p>
@@ -1799,7 +1799,7 @@
           <a:p>
             <a:r>
               <a:rPr lang="en-US" dirty="0"/>
-              <a:t>MOHAMED (0:50). The workflow is one file, .github/workflows/ci-cd.yml, and it runs on every push and every pull request. Four things happen in order. Ruff lints the whole repository. Pytest runs our 34 tests against the real model artifact, not a stub. Then Docker builds the image — and this is the part I want to highlight — CI does not just build it, it starts the container, waits for it, checks that health reports the model as loaded, posts a real transaction to predict and asserts the probability is in range, and sends a broken payload to confirm it gets a 422. Only if all of that passes, and only on the main branch, does the deploy job fire the Render deploy hook, which is stored as a GitHub secret and never appears in the code. We deliberately turned Render's own auto-deploy off, so nothing reaches production without passing CI first. The run on screen is the latest successful one on main, where all three jobs passed and the deploy job released the version that is serving right now.</a:t>
+              <a:t>MOHAMED (0:50). The workflow is one file, .github/workflows/ci-cd.yml, and it runs on every push and every pull request. Four things happen in order. Ruff lints the whole repository. Pytest runs our 37 tests against the real model artifact, not a stub. Then Docker builds the image — and this is the part I want to highlight — CI does not just build it, it starts the container, waits for it, checks that health reports the model as loaded, posts a real transaction to predict and asserts the probability is in range, and sends a broken payload to confirm it gets a 422. Only if all of that passes, and only on the main branch, does the deploy job fire the Render deploy hook, which is stored as a GitHub secret and never appears in the code. We deliberately turned Render's own auto-deploy off, so nothing reaches production without passing CI first. The run on screen is the latest successful one on main, where all three jobs passed and the deploy job released the version that is serving right now.</a:t>
             </a:r>
             <a:endParaRPr lang="en-US" dirty="0"/>
           </a:p>
@@ -3757,7 +3757,7 @@
                 <a:ea typeface="Calibri" pitchFamily="34" charset="-122"/>
                 <a:cs typeface="Calibri" pitchFamily="34" charset="-120"/>
               </a:rPr>
-              <a:t>Open the public Swagger UI</a:t>
+              <a:t>Open the public browser demo</a:t>
             </a:r>
             <a:endParaRPr lang="en-US" sz="1300" dirty="0"/>
           </a:p>
@@ -3796,7 +3796,7 @@
                 <a:ea typeface="Courier New" pitchFamily="34" charset="-122"/>
                 <a:cs typeface="Courier New" pitchFamily="34" charset="-120"/>
               </a:rPr>
-              <a:t>https://mai201-fraud-api.onrender.com/docs</a:t>
+              <a:t>https://mai201-fraud-api.onrender.com</a:t>
             </a:r>
             <a:endParaRPr lang="en-US" sz="1000" dirty="0"/>
           </a:p>
@@ -4095,7 +4095,7 @@
                 <a:ea typeface="Calibri" pitchFamily="34" charset="-122"/>
                 <a:cs typeface="Calibri" pitchFamily="34" charset="-120"/>
               </a:rPr>
-              <a:t>POST a real fraud transaction</a:t>
+              <a:t>Analyze a real fraud transaction</a:t>
             </a:r>
             <a:endParaRPr lang="en-US" sz="1300" dirty="0"/>
           </a:p>
@@ -7607,7 +7607,7 @@
       </p:sp>
       <p:pic>
         <p:nvPicPr>
-          <p:cNvPr id="5" name="Image 0" descr="/sessions/focused-compassionate-galileo/mnt/mlops-creditcard/docs/architecture_phase2.png">    </p:cNvPr>
+          <p:cNvPr id="5" name="Image 0" descr="/sessions/focused-compassionate-galileo/mnt/Project/MAI201_CreditCardFraud_Phase_2/MLops-credit-card-fraud/docs/architecture_phase2.png">    </p:cNvPr>
           <p:cNvPicPr>
             <a:picLocks noChangeAspect="1"/>
           </p:cNvPicPr>
@@ -9823,7 +9823,7 @@
                 <a:ea typeface="Calibri" pitchFamily="34" charset="-122"/>
                 <a:cs typeface="Calibri" pitchFamily="34" charset="-120"/>
               </a:rPr>
-              <a:t>Swagger UI at https://mai201-fraud-api.onrender.com/docs   ·   released automatically by the latest successful CI/CD run</a:t>
+              <a:t>Browser demo at https://mai201-fraud-api.onrender.com   ·   Swagger UI at https://mai201-fraud-api.onrender.com/docs   ·   released automatically by CI/CD</a:t>
             </a:r>
             <a:endParaRPr lang="en-US" sz="1100" dirty="0"/>
           </a:p>
@@ -10337,7 +10337,7 @@
                 <a:ea typeface="Calibri" pitchFamily="34" charset="-122"/>
                 <a:cs typeface="Calibri" pitchFamily="34" charset="-120"/>
               </a:rPr>
-              <a:t>34 tests against the real model</a:t>
+              <a:t>37 tests against the real model</a:t>
             </a:r>
             <a:endParaRPr lang="en-US" sz="1050" dirty="0"/>
           </a:p>

</xml_diff>